<commit_message>
Start marking demo bookmarks.
</commit_message>
<xml_diff>
--- a/Telemetry/Logging Hero.pptx
+++ b/Telemetry/Logging Hero.pptx
@@ -255,7 +255,7 @@
           <a:p>
             <a:fld id="{574E8BCA-0B4F-4373-B78E-3D2899449797}" type="datetimeFigureOut">
               <a:rPr lang="en-US" smtClean="0"/>
-              <a:t>5/12/2025</a:t>
+              <a:t>9/7/2026</a:t>
             </a:fld>
             <a:endParaRPr lang="en-US" dirty="0"/>
           </a:p>
@@ -5652,7 +5652,7 @@
         </p:blipFill>
         <p:spPr>
           <a:xfrm>
-            <a:off x="40079" y="2193343"/>
+            <a:off x="-2632895" y="6376643"/>
             <a:ext cx="12111841" cy="3088191"/>
           </a:xfrm>
           <a:prstGeom prst="rect">
@@ -5689,7 +5689,7 @@
         </p:blipFill>
         <p:spPr bwMode="auto">
           <a:xfrm>
-            <a:off x="8857510" y="4377690"/>
+            <a:off x="1434847" y="3754278"/>
             <a:ext cx="3065252" cy="2301240"/>
           </a:xfrm>
           <a:prstGeom prst="rect">
@@ -5707,6 +5707,1039 @@
           </a:extLst>
         </p:spPr>
       </p:pic>
+      <p:sp>
+        <p:nvSpPr>
+          <p:cNvPr id="2" name="Rectangle 1">
+            <a:extLst>
+              <a:ext uri="{FF2B5EF4-FFF2-40B4-BE49-F238E27FC236}">
+                <a16:creationId xmlns:a16="http://schemas.microsoft.com/office/drawing/2014/main" id="{DD2AFF11-46EA-2F87-DFF2-0FB3D1C0BEC2}"/>
+              </a:ext>
+            </a:extLst>
+          </p:cNvPr>
+          <p:cNvSpPr/>
+          <p:nvPr/>
+        </p:nvSpPr>
+        <p:spPr bwMode="auto">
+          <a:xfrm>
+            <a:off x="269239" y="2461516"/>
+            <a:ext cx="2331217" cy="632737"/>
+          </a:xfrm>
+          <a:prstGeom prst="rect">
+            <a:avLst/>
+          </a:prstGeom>
+          <a:ln>
+            <a:noFill/>
+            <a:headEnd type="none" w="med" len="med"/>
+            <a:tailEnd type="none" w="med" len="med"/>
+          </a:ln>
+        </p:spPr>
+        <p:style>
+          <a:lnRef idx="2">
+            <a:schemeClr val="accent1">
+              <a:shade val="50000"/>
+            </a:schemeClr>
+          </a:lnRef>
+          <a:fillRef idx="1">
+            <a:schemeClr val="accent1"/>
+          </a:fillRef>
+          <a:effectRef idx="0">
+            <a:schemeClr val="accent1"/>
+          </a:effectRef>
+          <a:fontRef idx="minor">
+            <a:schemeClr val="lt1"/>
+          </a:fontRef>
+        </p:style>
+        <p:txBody>
+          <a:bodyPr vert="horz" wrap="square" lIns="0" tIns="46637" rIns="0" bIns="46637" numCol="1" rtlCol="0" anchor="ctr" anchorCtr="0" compatLnSpc="1">
+            <a:prstTxWarp prst="textNoShape">
+              <a:avLst/>
+            </a:prstTxWarp>
+          </a:bodyPr>
+          <a:lstStyle/>
+          <a:p>
+            <a:pPr algn="ctr" defTabSz="932472" fontAlgn="base">
+              <a:spcBef>
+                <a:spcPct val="0"/>
+              </a:spcBef>
+              <a:spcAft>
+                <a:spcPct val="0"/>
+              </a:spcAft>
+            </a:pPr>
+            <a:r>
+              <a:rPr lang="en-US" sz="2000" dirty="0">
+                <a:gradFill>
+                  <a:gsLst>
+                    <a:gs pos="0">
+                      <a:srgbClr val="FFFFFF"/>
+                    </a:gs>
+                    <a:gs pos="100000">
+                      <a:srgbClr val="FFFFFF"/>
+                    </a:gs>
+                  </a:gsLst>
+                  <a:lin ang="5400000" scaled="0"/>
+                </a:gradFill>
+              </a:rPr>
+              <a:t>OTLP endpoint</a:t>
+            </a:r>
+          </a:p>
+        </p:txBody>
+      </p:sp>
+      <p:sp>
+        <p:nvSpPr>
+          <p:cNvPr id="6" name="Rectangle 5">
+            <a:extLst>
+              <a:ext uri="{FF2B5EF4-FFF2-40B4-BE49-F238E27FC236}">
+                <a16:creationId xmlns:a16="http://schemas.microsoft.com/office/drawing/2014/main" id="{3AEE981B-7BD6-6080-3EEF-199177BBC3C5}"/>
+              </a:ext>
+            </a:extLst>
+          </p:cNvPr>
+          <p:cNvSpPr/>
+          <p:nvPr/>
+        </p:nvSpPr>
+        <p:spPr bwMode="auto">
+          <a:xfrm>
+            <a:off x="3064356" y="2461516"/>
+            <a:ext cx="2331217" cy="632737"/>
+          </a:xfrm>
+          <a:prstGeom prst="rect">
+            <a:avLst/>
+          </a:prstGeom>
+          <a:ln>
+            <a:noFill/>
+            <a:headEnd type="none" w="med" len="med"/>
+            <a:tailEnd type="none" w="med" len="med"/>
+          </a:ln>
+        </p:spPr>
+        <p:style>
+          <a:lnRef idx="2">
+            <a:schemeClr val="accent1">
+              <a:shade val="50000"/>
+            </a:schemeClr>
+          </a:lnRef>
+          <a:fillRef idx="1">
+            <a:schemeClr val="accent1"/>
+          </a:fillRef>
+          <a:effectRef idx="0">
+            <a:schemeClr val="accent1"/>
+          </a:effectRef>
+          <a:fontRef idx="minor">
+            <a:schemeClr val="lt1"/>
+          </a:fontRef>
+        </p:style>
+        <p:txBody>
+          <a:bodyPr vert="horz" wrap="square" lIns="0" tIns="46637" rIns="0" bIns="46637" numCol="1" rtlCol="0" anchor="ctr" anchorCtr="0" compatLnSpc="1">
+            <a:prstTxWarp prst="textNoShape">
+              <a:avLst/>
+            </a:prstTxWarp>
+          </a:bodyPr>
+          <a:lstStyle/>
+          <a:p>
+            <a:pPr algn="ctr" defTabSz="932472" fontAlgn="base">
+              <a:spcBef>
+                <a:spcPct val="0"/>
+              </a:spcBef>
+              <a:spcAft>
+                <a:spcPct val="0"/>
+              </a:spcAft>
+            </a:pPr>
+            <a:r>
+              <a:rPr lang="en-US" sz="2000" dirty="0">
+                <a:gradFill>
+                  <a:gsLst>
+                    <a:gs pos="0">
+                      <a:srgbClr val="FFFFFF"/>
+                    </a:gs>
+                    <a:gs pos="100000">
+                      <a:srgbClr val="FFFFFF"/>
+                    </a:gs>
+                  </a:gsLst>
+                  <a:lin ang="5400000" scaled="0"/>
+                </a:gradFill>
+              </a:rPr>
+              <a:t>OTEL Collector</a:t>
+            </a:r>
+          </a:p>
+        </p:txBody>
+      </p:sp>
+      <p:sp>
+        <p:nvSpPr>
+          <p:cNvPr id="9" name="Rectangle 8">
+            <a:extLst>
+              <a:ext uri="{FF2B5EF4-FFF2-40B4-BE49-F238E27FC236}">
+                <a16:creationId xmlns:a16="http://schemas.microsoft.com/office/drawing/2014/main" id="{EF5C5986-5142-81D8-A07A-3B0C6542FB44}"/>
+              </a:ext>
+            </a:extLst>
+          </p:cNvPr>
+          <p:cNvSpPr/>
+          <p:nvPr/>
+        </p:nvSpPr>
+        <p:spPr bwMode="auto">
+          <a:xfrm>
+            <a:off x="6482635" y="2210637"/>
+            <a:ext cx="2331217" cy="395426"/>
+          </a:xfrm>
+          <a:prstGeom prst="rect">
+            <a:avLst/>
+          </a:prstGeom>
+          <a:ln>
+            <a:noFill/>
+            <a:headEnd type="none" w="med" len="med"/>
+            <a:tailEnd type="none" w="med" len="med"/>
+          </a:ln>
+        </p:spPr>
+        <p:style>
+          <a:lnRef idx="2">
+            <a:schemeClr val="accent1">
+              <a:shade val="50000"/>
+            </a:schemeClr>
+          </a:lnRef>
+          <a:fillRef idx="1">
+            <a:schemeClr val="accent1"/>
+          </a:fillRef>
+          <a:effectRef idx="0">
+            <a:schemeClr val="accent1"/>
+          </a:effectRef>
+          <a:fontRef idx="minor">
+            <a:schemeClr val="lt1"/>
+          </a:fontRef>
+        </p:style>
+        <p:txBody>
+          <a:bodyPr vert="horz" wrap="square" lIns="0" tIns="46637" rIns="0" bIns="46637" numCol="1" rtlCol="0" anchor="ctr" anchorCtr="0" compatLnSpc="1">
+            <a:prstTxWarp prst="textNoShape">
+              <a:avLst/>
+            </a:prstTxWarp>
+          </a:bodyPr>
+          <a:lstStyle/>
+          <a:p>
+            <a:pPr algn="ctr" defTabSz="932472" fontAlgn="base">
+              <a:spcBef>
+                <a:spcPct val="0"/>
+              </a:spcBef>
+              <a:spcAft>
+                <a:spcPct val="0"/>
+              </a:spcAft>
+            </a:pPr>
+            <a:r>
+              <a:rPr lang="en-US" sz="2000" dirty="0">
+                <a:gradFill>
+                  <a:gsLst>
+                    <a:gs pos="0">
+                      <a:srgbClr val="FFFFFF"/>
+                    </a:gs>
+                    <a:gs pos="100000">
+                      <a:srgbClr val="FFFFFF"/>
+                    </a:gs>
+                  </a:gsLst>
+                  <a:lin ang="5400000" scaled="0"/>
+                </a:gradFill>
+              </a:rPr>
+              <a:t>Seq</a:t>
+            </a:r>
+          </a:p>
+        </p:txBody>
+      </p:sp>
+      <p:sp>
+        <p:nvSpPr>
+          <p:cNvPr id="11" name="Rectangle 10">
+            <a:extLst>
+              <a:ext uri="{FF2B5EF4-FFF2-40B4-BE49-F238E27FC236}">
+                <a16:creationId xmlns:a16="http://schemas.microsoft.com/office/drawing/2014/main" id="{0D914A86-79D1-1769-DE0B-9AB0163A2D8C}"/>
+              </a:ext>
+            </a:extLst>
+          </p:cNvPr>
+          <p:cNvSpPr/>
+          <p:nvPr/>
+        </p:nvSpPr>
+        <p:spPr bwMode="auto">
+          <a:xfrm>
+            <a:off x="6487772" y="2706188"/>
+            <a:ext cx="2331217" cy="395426"/>
+          </a:xfrm>
+          <a:prstGeom prst="rect">
+            <a:avLst/>
+          </a:prstGeom>
+          <a:ln>
+            <a:noFill/>
+            <a:headEnd type="none" w="med" len="med"/>
+            <a:tailEnd type="none" w="med" len="med"/>
+          </a:ln>
+        </p:spPr>
+        <p:style>
+          <a:lnRef idx="2">
+            <a:schemeClr val="accent1">
+              <a:shade val="50000"/>
+            </a:schemeClr>
+          </a:lnRef>
+          <a:fillRef idx="1">
+            <a:schemeClr val="accent1"/>
+          </a:fillRef>
+          <a:effectRef idx="0">
+            <a:schemeClr val="accent1"/>
+          </a:effectRef>
+          <a:fontRef idx="minor">
+            <a:schemeClr val="lt1"/>
+          </a:fontRef>
+        </p:style>
+        <p:txBody>
+          <a:bodyPr vert="horz" wrap="square" lIns="0" tIns="46637" rIns="0" bIns="46637" numCol="1" rtlCol="0" anchor="ctr" anchorCtr="0" compatLnSpc="1">
+            <a:prstTxWarp prst="textNoShape">
+              <a:avLst/>
+            </a:prstTxWarp>
+          </a:bodyPr>
+          <a:lstStyle/>
+          <a:p>
+            <a:pPr algn="ctr" defTabSz="932472" fontAlgn="base">
+              <a:spcBef>
+                <a:spcPct val="0"/>
+              </a:spcBef>
+              <a:spcAft>
+                <a:spcPct val="0"/>
+              </a:spcAft>
+            </a:pPr>
+            <a:r>
+              <a:rPr lang="en-US" sz="2000" dirty="0">
+                <a:gradFill>
+                  <a:gsLst>
+                    <a:gs pos="0">
+                      <a:srgbClr val="FFFFFF"/>
+                    </a:gs>
+                    <a:gs pos="100000">
+                      <a:srgbClr val="FFFFFF"/>
+                    </a:gs>
+                  </a:gsLst>
+                  <a:lin ang="5400000" scaled="0"/>
+                </a:gradFill>
+              </a:rPr>
+              <a:t>Aspire</a:t>
+            </a:r>
+          </a:p>
+        </p:txBody>
+      </p:sp>
+      <p:sp>
+        <p:nvSpPr>
+          <p:cNvPr id="13" name="Rectangle 12">
+            <a:extLst>
+              <a:ext uri="{FF2B5EF4-FFF2-40B4-BE49-F238E27FC236}">
+                <a16:creationId xmlns:a16="http://schemas.microsoft.com/office/drawing/2014/main" id="{387F89A1-102E-E70A-2D74-9A852E23DD32}"/>
+              </a:ext>
+            </a:extLst>
+          </p:cNvPr>
+          <p:cNvSpPr/>
+          <p:nvPr/>
+        </p:nvSpPr>
+        <p:spPr bwMode="auto">
+          <a:xfrm>
+            <a:off x="6482633" y="3205682"/>
+            <a:ext cx="2331217" cy="395426"/>
+          </a:xfrm>
+          <a:prstGeom prst="rect">
+            <a:avLst/>
+          </a:prstGeom>
+          <a:ln>
+            <a:noFill/>
+            <a:headEnd type="none" w="med" len="med"/>
+            <a:tailEnd type="none" w="med" len="med"/>
+          </a:ln>
+        </p:spPr>
+        <p:style>
+          <a:lnRef idx="2">
+            <a:schemeClr val="accent1">
+              <a:shade val="50000"/>
+            </a:schemeClr>
+          </a:lnRef>
+          <a:fillRef idx="1">
+            <a:schemeClr val="accent1"/>
+          </a:fillRef>
+          <a:effectRef idx="0">
+            <a:schemeClr val="accent1"/>
+          </a:effectRef>
+          <a:fontRef idx="minor">
+            <a:schemeClr val="lt1"/>
+          </a:fontRef>
+        </p:style>
+        <p:txBody>
+          <a:bodyPr vert="horz" wrap="square" lIns="0" tIns="46637" rIns="0" bIns="46637" numCol="1" rtlCol="0" anchor="ctr" anchorCtr="0" compatLnSpc="1">
+            <a:prstTxWarp prst="textNoShape">
+              <a:avLst/>
+            </a:prstTxWarp>
+          </a:bodyPr>
+          <a:lstStyle/>
+          <a:p>
+            <a:pPr algn="ctr" defTabSz="932472" fontAlgn="base">
+              <a:spcBef>
+                <a:spcPct val="0"/>
+              </a:spcBef>
+              <a:spcAft>
+                <a:spcPct val="0"/>
+              </a:spcAft>
+            </a:pPr>
+            <a:r>
+              <a:rPr lang="en-US" sz="2000" dirty="0">
+                <a:gradFill>
+                  <a:gsLst>
+                    <a:gs pos="0">
+                      <a:srgbClr val="FFFFFF"/>
+                    </a:gs>
+                    <a:gs pos="100000">
+                      <a:srgbClr val="FFFFFF"/>
+                    </a:gs>
+                  </a:gsLst>
+                  <a:lin ang="5400000" scaled="0"/>
+                </a:gradFill>
+              </a:rPr>
+              <a:t>Zipkin</a:t>
+            </a:r>
+          </a:p>
+        </p:txBody>
+      </p:sp>
+      <p:sp>
+        <p:nvSpPr>
+          <p:cNvPr id="15" name="Rectangle 14">
+            <a:extLst>
+              <a:ext uri="{FF2B5EF4-FFF2-40B4-BE49-F238E27FC236}">
+                <a16:creationId xmlns:a16="http://schemas.microsoft.com/office/drawing/2014/main" id="{09CA341E-713A-9D2E-A7CB-227C5636B491}"/>
+              </a:ext>
+            </a:extLst>
+          </p:cNvPr>
+          <p:cNvSpPr/>
+          <p:nvPr/>
+        </p:nvSpPr>
+        <p:spPr bwMode="auto">
+          <a:xfrm>
+            <a:off x="6482632" y="3696553"/>
+            <a:ext cx="2331217" cy="395426"/>
+          </a:xfrm>
+          <a:prstGeom prst="rect">
+            <a:avLst/>
+          </a:prstGeom>
+          <a:ln>
+            <a:noFill/>
+            <a:headEnd type="none" w="med" len="med"/>
+            <a:tailEnd type="none" w="med" len="med"/>
+          </a:ln>
+        </p:spPr>
+        <p:style>
+          <a:lnRef idx="2">
+            <a:schemeClr val="accent1">
+              <a:shade val="50000"/>
+            </a:schemeClr>
+          </a:lnRef>
+          <a:fillRef idx="1">
+            <a:schemeClr val="accent1"/>
+          </a:fillRef>
+          <a:effectRef idx="0">
+            <a:schemeClr val="accent1"/>
+          </a:effectRef>
+          <a:fontRef idx="minor">
+            <a:schemeClr val="lt1"/>
+          </a:fontRef>
+        </p:style>
+        <p:txBody>
+          <a:bodyPr vert="horz" wrap="square" lIns="0" tIns="46637" rIns="0" bIns="46637" numCol="1" rtlCol="0" anchor="ctr" anchorCtr="0" compatLnSpc="1">
+            <a:prstTxWarp prst="textNoShape">
+              <a:avLst/>
+            </a:prstTxWarp>
+          </a:bodyPr>
+          <a:lstStyle/>
+          <a:p>
+            <a:pPr algn="ctr" defTabSz="932472" fontAlgn="base">
+              <a:spcBef>
+                <a:spcPct val="0"/>
+              </a:spcBef>
+              <a:spcAft>
+                <a:spcPct val="0"/>
+              </a:spcAft>
+            </a:pPr>
+            <a:r>
+              <a:rPr lang="en-US" sz="2000" dirty="0">
+                <a:gradFill>
+                  <a:gsLst>
+                    <a:gs pos="0">
+                      <a:srgbClr val="FFFFFF"/>
+                    </a:gs>
+                    <a:gs pos="100000">
+                      <a:srgbClr val="FFFFFF"/>
+                    </a:gs>
+                  </a:gsLst>
+                  <a:lin ang="5400000" scaled="0"/>
+                </a:gradFill>
+              </a:rPr>
+              <a:t>Prometheus</a:t>
+            </a:r>
+          </a:p>
+        </p:txBody>
+      </p:sp>
+      <p:sp>
+        <p:nvSpPr>
+          <p:cNvPr id="17" name="Rectangle 16">
+            <a:extLst>
+              <a:ext uri="{FF2B5EF4-FFF2-40B4-BE49-F238E27FC236}">
+                <a16:creationId xmlns:a16="http://schemas.microsoft.com/office/drawing/2014/main" id="{C1C391F2-A9A2-CE1A-C7D2-D0C8D1D5E82F}"/>
+              </a:ext>
+            </a:extLst>
+          </p:cNvPr>
+          <p:cNvSpPr/>
+          <p:nvPr/>
+        </p:nvSpPr>
+        <p:spPr bwMode="auto">
+          <a:xfrm>
+            <a:off x="9408607" y="3696554"/>
+            <a:ext cx="2331217" cy="395426"/>
+          </a:xfrm>
+          <a:prstGeom prst="rect">
+            <a:avLst/>
+          </a:prstGeom>
+          <a:ln>
+            <a:noFill/>
+            <a:headEnd type="none" w="med" len="med"/>
+            <a:tailEnd type="none" w="med" len="med"/>
+          </a:ln>
+        </p:spPr>
+        <p:style>
+          <a:lnRef idx="2">
+            <a:schemeClr val="accent1">
+              <a:shade val="50000"/>
+            </a:schemeClr>
+          </a:lnRef>
+          <a:fillRef idx="1">
+            <a:schemeClr val="accent1"/>
+          </a:fillRef>
+          <a:effectRef idx="0">
+            <a:schemeClr val="accent1"/>
+          </a:effectRef>
+          <a:fontRef idx="minor">
+            <a:schemeClr val="lt1"/>
+          </a:fontRef>
+        </p:style>
+        <p:txBody>
+          <a:bodyPr vert="horz" wrap="square" lIns="0" tIns="46637" rIns="0" bIns="46637" numCol="1" rtlCol="0" anchor="ctr" anchorCtr="0" compatLnSpc="1">
+            <a:prstTxWarp prst="textNoShape">
+              <a:avLst/>
+            </a:prstTxWarp>
+          </a:bodyPr>
+          <a:lstStyle/>
+          <a:p>
+            <a:pPr algn="ctr" defTabSz="932472" fontAlgn="base">
+              <a:spcBef>
+                <a:spcPct val="0"/>
+              </a:spcBef>
+              <a:spcAft>
+                <a:spcPct val="0"/>
+              </a:spcAft>
+            </a:pPr>
+            <a:r>
+              <a:rPr lang="en-US" sz="2000" dirty="0">
+                <a:gradFill>
+                  <a:gsLst>
+                    <a:gs pos="0">
+                      <a:srgbClr val="FFFFFF"/>
+                    </a:gs>
+                    <a:gs pos="100000">
+                      <a:srgbClr val="FFFFFF"/>
+                    </a:gs>
+                  </a:gsLst>
+                  <a:lin ang="5400000" scaled="0"/>
+                </a:gradFill>
+              </a:rPr>
+              <a:t>Grafana</a:t>
+            </a:r>
+          </a:p>
+        </p:txBody>
+      </p:sp>
+      <p:sp>
+        <p:nvSpPr>
+          <p:cNvPr id="19" name="Rectangle 18">
+            <a:extLst>
+              <a:ext uri="{FF2B5EF4-FFF2-40B4-BE49-F238E27FC236}">
+                <a16:creationId xmlns:a16="http://schemas.microsoft.com/office/drawing/2014/main" id="{F97764E4-56E3-68C1-B902-57C3B77073AE}"/>
+              </a:ext>
+            </a:extLst>
+          </p:cNvPr>
+          <p:cNvSpPr/>
+          <p:nvPr/>
+        </p:nvSpPr>
+        <p:spPr bwMode="auto">
+          <a:xfrm>
+            <a:off x="6482631" y="4170572"/>
+            <a:ext cx="2331217" cy="395426"/>
+          </a:xfrm>
+          <a:prstGeom prst="rect">
+            <a:avLst/>
+          </a:prstGeom>
+          <a:ln>
+            <a:noFill/>
+            <a:headEnd type="none" w="med" len="med"/>
+            <a:tailEnd type="none" w="med" len="med"/>
+          </a:ln>
+        </p:spPr>
+        <p:style>
+          <a:lnRef idx="2">
+            <a:schemeClr val="accent1">
+              <a:shade val="50000"/>
+            </a:schemeClr>
+          </a:lnRef>
+          <a:fillRef idx="1">
+            <a:schemeClr val="accent1"/>
+          </a:fillRef>
+          <a:effectRef idx="0">
+            <a:schemeClr val="accent1"/>
+          </a:effectRef>
+          <a:fontRef idx="minor">
+            <a:schemeClr val="lt1"/>
+          </a:fontRef>
+        </p:style>
+        <p:txBody>
+          <a:bodyPr vert="horz" wrap="square" lIns="0" tIns="46637" rIns="0" bIns="46637" numCol="1" rtlCol="0" anchor="ctr" anchorCtr="0" compatLnSpc="1">
+            <a:prstTxWarp prst="textNoShape">
+              <a:avLst/>
+            </a:prstTxWarp>
+          </a:bodyPr>
+          <a:lstStyle/>
+          <a:p>
+            <a:pPr algn="ctr" defTabSz="932472" fontAlgn="base">
+              <a:spcBef>
+                <a:spcPct val="0"/>
+              </a:spcBef>
+              <a:spcAft>
+                <a:spcPct val="0"/>
+              </a:spcAft>
+            </a:pPr>
+            <a:r>
+              <a:rPr lang="en-US" sz="2000" dirty="0">
+                <a:gradFill>
+                  <a:gsLst>
+                    <a:gs pos="0">
+                      <a:srgbClr val="FFFFFF"/>
+                    </a:gs>
+                    <a:gs pos="100000">
+                      <a:srgbClr val="FFFFFF"/>
+                    </a:gs>
+                  </a:gsLst>
+                  <a:lin ang="5400000" scaled="0"/>
+                </a:gradFill>
+              </a:rPr>
+              <a:t>Jaeger</a:t>
+            </a:r>
+          </a:p>
+        </p:txBody>
+      </p:sp>
+      <p:sp>
+        <p:nvSpPr>
+          <p:cNvPr id="21" name="Rectangle 20">
+            <a:extLst>
+              <a:ext uri="{FF2B5EF4-FFF2-40B4-BE49-F238E27FC236}">
+                <a16:creationId xmlns:a16="http://schemas.microsoft.com/office/drawing/2014/main" id="{2BCA6A0A-72F1-90B4-F012-85F5DB6C6F57}"/>
+              </a:ext>
+            </a:extLst>
+          </p:cNvPr>
+          <p:cNvSpPr/>
+          <p:nvPr/>
+        </p:nvSpPr>
+        <p:spPr bwMode="auto">
+          <a:xfrm>
+            <a:off x="6482630" y="5062548"/>
+            <a:ext cx="2331217" cy="395426"/>
+          </a:xfrm>
+          <a:prstGeom prst="rect">
+            <a:avLst/>
+          </a:prstGeom>
+          <a:ln>
+            <a:headEnd type="none" w="med" len="med"/>
+            <a:tailEnd type="none" w="med" len="med"/>
+          </a:ln>
+        </p:spPr>
+        <p:style>
+          <a:lnRef idx="2">
+            <a:schemeClr val="accent6"/>
+          </a:lnRef>
+          <a:fillRef idx="1">
+            <a:schemeClr val="lt1"/>
+          </a:fillRef>
+          <a:effectRef idx="0">
+            <a:schemeClr val="accent6"/>
+          </a:effectRef>
+          <a:fontRef idx="minor">
+            <a:schemeClr val="dk1"/>
+          </a:fontRef>
+        </p:style>
+        <p:txBody>
+          <a:bodyPr vert="horz" wrap="square" lIns="0" tIns="46637" rIns="0" bIns="46637" numCol="1" rtlCol="0" anchor="ctr" anchorCtr="0" compatLnSpc="1">
+            <a:prstTxWarp prst="textNoShape">
+              <a:avLst/>
+            </a:prstTxWarp>
+          </a:bodyPr>
+          <a:lstStyle/>
+          <a:p>
+            <a:pPr algn="ctr" defTabSz="932472" fontAlgn="base">
+              <a:spcBef>
+                <a:spcPct val="0"/>
+              </a:spcBef>
+              <a:spcAft>
+                <a:spcPct val="0"/>
+              </a:spcAft>
+            </a:pPr>
+            <a:r>
+              <a:rPr lang="en-US" sz="2000" dirty="0">
+                <a:solidFill>
+                  <a:schemeClr val="bg1"/>
+                </a:solidFill>
+              </a:rPr>
+              <a:t>Honeycomb</a:t>
+            </a:r>
+          </a:p>
+        </p:txBody>
+      </p:sp>
+      <p:cxnSp>
+        <p:nvCxnSpPr>
+          <p:cNvPr id="23" name="Straight Arrow Connector 22">
+            <a:extLst>
+              <a:ext uri="{FF2B5EF4-FFF2-40B4-BE49-F238E27FC236}">
+                <a16:creationId xmlns:a16="http://schemas.microsoft.com/office/drawing/2014/main" id="{9C0D9FBA-20AE-338B-CE9B-AD8764124D80}"/>
+              </a:ext>
+            </a:extLst>
+          </p:cNvPr>
+          <p:cNvCxnSpPr>
+            <a:stCxn id="2" idx="3"/>
+            <a:endCxn id="6" idx="1"/>
+          </p:cNvCxnSpPr>
+          <p:nvPr/>
+        </p:nvCxnSpPr>
+        <p:spPr>
+          <a:xfrm>
+            <a:off x="2600456" y="2777885"/>
+            <a:ext cx="463900" cy="0"/>
+          </a:xfrm>
+          <a:prstGeom prst="straightConnector1">
+            <a:avLst/>
+          </a:prstGeom>
+          <a:ln>
+            <a:headEnd type="none"/>
+            <a:tailEnd type="triangle"/>
+          </a:ln>
+        </p:spPr>
+        <p:style>
+          <a:lnRef idx="1">
+            <a:schemeClr val="dk1"/>
+          </a:lnRef>
+          <a:fillRef idx="0">
+            <a:schemeClr val="dk1"/>
+          </a:fillRef>
+          <a:effectRef idx="0">
+            <a:schemeClr val="dk1"/>
+          </a:effectRef>
+          <a:fontRef idx="minor">
+            <a:schemeClr val="tx1"/>
+          </a:fontRef>
+        </p:style>
+      </p:cxnSp>
+      <p:cxnSp>
+        <p:nvCxnSpPr>
+          <p:cNvPr id="24" name="Straight Arrow Connector 23">
+            <a:extLst>
+              <a:ext uri="{FF2B5EF4-FFF2-40B4-BE49-F238E27FC236}">
+                <a16:creationId xmlns:a16="http://schemas.microsoft.com/office/drawing/2014/main" id="{57CE0FEB-0E0C-C326-C0EE-CD450B989056}"/>
+              </a:ext>
+            </a:extLst>
+          </p:cNvPr>
+          <p:cNvCxnSpPr>
+            <a:cxnSpLocks/>
+            <a:stCxn id="6" idx="3"/>
+            <a:endCxn id="9" idx="1"/>
+          </p:cNvCxnSpPr>
+          <p:nvPr/>
+        </p:nvCxnSpPr>
+        <p:spPr>
+          <a:xfrm flipV="1">
+            <a:off x="5395573" y="2408350"/>
+            <a:ext cx="1087062" cy="369535"/>
+          </a:xfrm>
+          <a:prstGeom prst="straightConnector1">
+            <a:avLst/>
+          </a:prstGeom>
+          <a:ln>
+            <a:headEnd type="none"/>
+            <a:tailEnd type="triangle"/>
+          </a:ln>
+        </p:spPr>
+        <p:style>
+          <a:lnRef idx="1">
+            <a:schemeClr val="dk1"/>
+          </a:lnRef>
+          <a:fillRef idx="0">
+            <a:schemeClr val="dk1"/>
+          </a:fillRef>
+          <a:effectRef idx="0">
+            <a:schemeClr val="dk1"/>
+          </a:effectRef>
+          <a:fontRef idx="minor">
+            <a:schemeClr val="tx1"/>
+          </a:fontRef>
+        </p:style>
+      </p:cxnSp>
+      <p:cxnSp>
+        <p:nvCxnSpPr>
+          <p:cNvPr id="27" name="Straight Arrow Connector 26">
+            <a:extLst>
+              <a:ext uri="{FF2B5EF4-FFF2-40B4-BE49-F238E27FC236}">
+                <a16:creationId xmlns:a16="http://schemas.microsoft.com/office/drawing/2014/main" id="{953467D8-E06F-10F4-8723-492AAC3247BD}"/>
+              </a:ext>
+            </a:extLst>
+          </p:cNvPr>
+          <p:cNvCxnSpPr>
+            <a:cxnSpLocks/>
+            <a:stCxn id="6" idx="3"/>
+            <a:endCxn id="11" idx="1"/>
+          </p:cNvCxnSpPr>
+          <p:nvPr/>
+        </p:nvCxnSpPr>
+        <p:spPr>
+          <a:xfrm>
+            <a:off x="5395573" y="2777885"/>
+            <a:ext cx="1092199" cy="126016"/>
+          </a:xfrm>
+          <a:prstGeom prst="straightConnector1">
+            <a:avLst/>
+          </a:prstGeom>
+          <a:ln>
+            <a:headEnd type="none"/>
+            <a:tailEnd type="triangle"/>
+          </a:ln>
+        </p:spPr>
+        <p:style>
+          <a:lnRef idx="1">
+            <a:schemeClr val="dk1"/>
+          </a:lnRef>
+          <a:fillRef idx="0">
+            <a:schemeClr val="dk1"/>
+          </a:fillRef>
+          <a:effectRef idx="0">
+            <a:schemeClr val="dk1"/>
+          </a:effectRef>
+          <a:fontRef idx="minor">
+            <a:schemeClr val="tx1"/>
+          </a:fontRef>
+        </p:style>
+      </p:cxnSp>
+      <p:cxnSp>
+        <p:nvCxnSpPr>
+          <p:cNvPr id="30" name="Straight Arrow Connector 29">
+            <a:extLst>
+              <a:ext uri="{FF2B5EF4-FFF2-40B4-BE49-F238E27FC236}">
+                <a16:creationId xmlns:a16="http://schemas.microsoft.com/office/drawing/2014/main" id="{F9EE94AC-8531-591A-F718-268F2FFF34BF}"/>
+              </a:ext>
+            </a:extLst>
+          </p:cNvPr>
+          <p:cNvCxnSpPr>
+            <a:cxnSpLocks/>
+            <a:stCxn id="6" idx="3"/>
+            <a:endCxn id="13" idx="1"/>
+          </p:cNvCxnSpPr>
+          <p:nvPr/>
+        </p:nvCxnSpPr>
+        <p:spPr>
+          <a:xfrm>
+            <a:off x="5395573" y="2777885"/>
+            <a:ext cx="1087060" cy="625510"/>
+          </a:xfrm>
+          <a:prstGeom prst="straightConnector1">
+            <a:avLst/>
+          </a:prstGeom>
+          <a:ln>
+            <a:headEnd type="none"/>
+            <a:tailEnd type="triangle"/>
+          </a:ln>
+        </p:spPr>
+        <p:style>
+          <a:lnRef idx="1">
+            <a:schemeClr val="dk1"/>
+          </a:lnRef>
+          <a:fillRef idx="0">
+            <a:schemeClr val="dk1"/>
+          </a:fillRef>
+          <a:effectRef idx="0">
+            <a:schemeClr val="dk1"/>
+          </a:effectRef>
+          <a:fontRef idx="minor">
+            <a:schemeClr val="tx1"/>
+          </a:fontRef>
+        </p:style>
+      </p:cxnSp>
+      <p:cxnSp>
+        <p:nvCxnSpPr>
+          <p:cNvPr id="33" name="Straight Arrow Connector 32">
+            <a:extLst>
+              <a:ext uri="{FF2B5EF4-FFF2-40B4-BE49-F238E27FC236}">
+                <a16:creationId xmlns:a16="http://schemas.microsoft.com/office/drawing/2014/main" id="{24C009D1-D1CB-D718-2AD8-D0ECD147407B}"/>
+              </a:ext>
+            </a:extLst>
+          </p:cNvPr>
+          <p:cNvCxnSpPr>
+            <a:cxnSpLocks/>
+            <a:stCxn id="6" idx="3"/>
+            <a:endCxn id="15" idx="1"/>
+          </p:cNvCxnSpPr>
+          <p:nvPr/>
+        </p:nvCxnSpPr>
+        <p:spPr>
+          <a:xfrm>
+            <a:off x="5395573" y="2777885"/>
+            <a:ext cx="1087059" cy="1116381"/>
+          </a:xfrm>
+          <a:prstGeom prst="straightConnector1">
+            <a:avLst/>
+          </a:prstGeom>
+          <a:ln>
+            <a:headEnd type="none"/>
+            <a:tailEnd type="triangle"/>
+          </a:ln>
+        </p:spPr>
+        <p:style>
+          <a:lnRef idx="1">
+            <a:schemeClr val="dk1"/>
+          </a:lnRef>
+          <a:fillRef idx="0">
+            <a:schemeClr val="dk1"/>
+          </a:fillRef>
+          <a:effectRef idx="0">
+            <a:schemeClr val="dk1"/>
+          </a:effectRef>
+          <a:fontRef idx="minor">
+            <a:schemeClr val="tx1"/>
+          </a:fontRef>
+        </p:style>
+      </p:cxnSp>
+      <p:cxnSp>
+        <p:nvCxnSpPr>
+          <p:cNvPr id="36" name="Straight Arrow Connector 35">
+            <a:extLst>
+              <a:ext uri="{FF2B5EF4-FFF2-40B4-BE49-F238E27FC236}">
+                <a16:creationId xmlns:a16="http://schemas.microsoft.com/office/drawing/2014/main" id="{D225CFDD-4A2A-2AF4-D219-2EB6B6DF03F3}"/>
+              </a:ext>
+            </a:extLst>
+          </p:cNvPr>
+          <p:cNvCxnSpPr>
+            <a:cxnSpLocks/>
+            <a:stCxn id="6" idx="3"/>
+            <a:endCxn id="19" idx="1"/>
+          </p:cNvCxnSpPr>
+          <p:nvPr/>
+        </p:nvCxnSpPr>
+        <p:spPr>
+          <a:xfrm>
+            <a:off x="5395573" y="2777885"/>
+            <a:ext cx="1087058" cy="1590400"/>
+          </a:xfrm>
+          <a:prstGeom prst="straightConnector1">
+            <a:avLst/>
+          </a:prstGeom>
+          <a:ln>
+            <a:headEnd type="none"/>
+            <a:tailEnd type="triangle"/>
+          </a:ln>
+        </p:spPr>
+        <p:style>
+          <a:lnRef idx="1">
+            <a:schemeClr val="dk1"/>
+          </a:lnRef>
+          <a:fillRef idx="0">
+            <a:schemeClr val="dk1"/>
+          </a:fillRef>
+          <a:effectRef idx="0">
+            <a:schemeClr val="dk1"/>
+          </a:effectRef>
+          <a:fontRef idx="minor">
+            <a:schemeClr val="tx1"/>
+          </a:fontRef>
+        </p:style>
+      </p:cxnSp>
+      <p:cxnSp>
+        <p:nvCxnSpPr>
+          <p:cNvPr id="39" name="Straight Arrow Connector 38">
+            <a:extLst>
+              <a:ext uri="{FF2B5EF4-FFF2-40B4-BE49-F238E27FC236}">
+                <a16:creationId xmlns:a16="http://schemas.microsoft.com/office/drawing/2014/main" id="{57177C14-EF68-3470-0F74-8B3241084902}"/>
+              </a:ext>
+            </a:extLst>
+          </p:cNvPr>
+          <p:cNvCxnSpPr>
+            <a:cxnSpLocks/>
+            <a:stCxn id="6" idx="3"/>
+            <a:endCxn id="21" idx="1"/>
+          </p:cNvCxnSpPr>
+          <p:nvPr/>
+        </p:nvCxnSpPr>
+        <p:spPr>
+          <a:xfrm>
+            <a:off x="5395573" y="2777885"/>
+            <a:ext cx="1087057" cy="2482376"/>
+          </a:xfrm>
+          <a:prstGeom prst="straightConnector1">
+            <a:avLst/>
+          </a:prstGeom>
+          <a:ln>
+            <a:headEnd type="none"/>
+            <a:tailEnd type="triangle"/>
+          </a:ln>
+        </p:spPr>
+        <p:style>
+          <a:lnRef idx="1">
+            <a:schemeClr val="dk1"/>
+          </a:lnRef>
+          <a:fillRef idx="0">
+            <a:schemeClr val="dk1"/>
+          </a:fillRef>
+          <a:effectRef idx="0">
+            <a:schemeClr val="dk1"/>
+          </a:effectRef>
+          <a:fontRef idx="minor">
+            <a:schemeClr val="tx1"/>
+          </a:fontRef>
+        </p:style>
+      </p:cxnSp>
+      <p:cxnSp>
+        <p:nvCxnSpPr>
+          <p:cNvPr id="42" name="Straight Arrow Connector 41">
+            <a:extLst>
+              <a:ext uri="{FF2B5EF4-FFF2-40B4-BE49-F238E27FC236}">
+                <a16:creationId xmlns:a16="http://schemas.microsoft.com/office/drawing/2014/main" id="{6DA80E6E-7525-2451-8BAF-D5AA93EA02C4}"/>
+              </a:ext>
+            </a:extLst>
+          </p:cNvPr>
+          <p:cNvCxnSpPr>
+            <a:cxnSpLocks/>
+            <a:stCxn id="15" idx="3"/>
+            <a:endCxn id="17" idx="1"/>
+          </p:cNvCxnSpPr>
+          <p:nvPr/>
+        </p:nvCxnSpPr>
+        <p:spPr>
+          <a:xfrm>
+            <a:off x="8813849" y="3894266"/>
+            <a:ext cx="594758" cy="1"/>
+          </a:xfrm>
+          <a:prstGeom prst="straightConnector1">
+            <a:avLst/>
+          </a:prstGeom>
+          <a:ln>
+            <a:headEnd type="none"/>
+            <a:tailEnd type="triangle"/>
+          </a:ln>
+        </p:spPr>
+        <p:style>
+          <a:lnRef idx="1">
+            <a:schemeClr val="dk1"/>
+          </a:lnRef>
+          <a:fillRef idx="0">
+            <a:schemeClr val="dk1"/>
+          </a:fillRef>
+          <a:effectRef idx="0">
+            <a:schemeClr val="dk1"/>
+          </a:effectRef>
+          <a:fontRef idx="minor">
+            <a:schemeClr val="tx1"/>
+          </a:fontRef>
+        </p:style>
+      </p:cxnSp>
     </p:spTree>
     <p:extLst>
       <p:ext uri="{BB962C8B-B14F-4D97-AF65-F5344CB8AC3E}">
@@ -5757,7 +6790,7 @@
           <a:p>
             <a:r>
               <a:rPr lang="en-US" dirty="0"/>
-              <a:t>Demo: Telemetry the Easy Way</a:t>
+              <a:t>Demo 1: Telemetry the Easy Way</a:t>
             </a:r>
           </a:p>
         </p:txBody>
@@ -6518,7 +7551,7 @@
           <a:p>
             <a:r>
               <a:rPr lang="en-US" dirty="0"/>
-              <a:t>Demo: Basic Semantic Logging</a:t>
+              <a:t>Demo 2: Basic Semantic Logging</a:t>
             </a:r>
           </a:p>
         </p:txBody>
@@ -6680,12 +7713,8 @@
               <a:buChar char="-"/>
             </a:pPr>
             <a:r>
-              <a:rPr lang="en-US" dirty="0" err="1"/>
-              <a:t>Graylog</a:t>
-            </a:r>
-            <a:r>
-              <a:rPr lang="en-US" dirty="0"/>
-              <a:t> cloud</a:t>
+              <a:rPr lang="en-US" dirty="0"/>
+              <a:t>Honeycomb</a:t>
             </a:r>
           </a:p>
           <a:p>
@@ -6695,6 +7724,20 @@
             </a:pPr>
             <a:r>
               <a:rPr lang="en-US" dirty="0" err="1"/>
+              <a:t>Graylog</a:t>
+            </a:r>
+            <a:r>
+              <a:rPr lang="en-US" dirty="0"/>
+              <a:t> cloud</a:t>
+            </a:r>
+          </a:p>
+          <a:p>
+            <a:pPr marL="796926" lvl="1" indent="-457200">
+              <a:buFontTx/>
+              <a:buChar char="-"/>
+            </a:pPr>
+            <a:r>
+              <a:rPr lang="en-US" dirty="0" err="1"/>
               <a:t>Papertrail</a:t>
             </a:r>
             <a:endParaRPr lang="en-US" dirty="0"/>
@@ -6718,16 +7761,9 @@
               <a:rPr lang="en-US" dirty="0" err="1"/>
               <a:t>Graylog</a:t>
             </a:r>
-            <a:endParaRPr lang="en-US" dirty="0"/>
-          </a:p>
-          <a:p>
-            <a:pPr marL="796926" lvl="1" indent="-457200">
-              <a:buFontTx/>
-              <a:buChar char="-"/>
-            </a:pPr>
-            <a:r>
-              <a:rPr lang="en-US" dirty="0"/>
-              <a:t>Seq</a:t>
+            <a:r>
+              <a:rPr lang="en-US" dirty="0"/>
+              <a:t>, Seq</a:t>
             </a:r>
           </a:p>
         </p:txBody>
@@ -6796,7 +7832,7 @@
 </file>
 
 <file path=ppt/slides/slide18.xml><?xml version="1.0" encoding="utf-8"?>
-<p:sld xmlns:a="http://schemas.openxmlformats.org/drawingml/2006/main" xmlns:r="http://schemas.openxmlformats.org/officeDocument/2006/relationships" xmlns:p="http://schemas.openxmlformats.org/presentationml/2006/main">
+<p:sld xmlns:a="http://schemas.openxmlformats.org/drawingml/2006/main" xmlns:r="http://schemas.openxmlformats.org/officeDocument/2006/relationships" xmlns:p="http://schemas.openxmlformats.org/presentationml/2006/main" show="0">
   <p:cSld>
     <p:spTree>
       <p:nvGrpSpPr>
@@ -7668,7 +8704,7 @@
           <a:p>
             <a:r>
               <a:rPr lang="en-US" dirty="0"/>
-              <a:t>Demo: Scopes</a:t>
+              <a:t>Demo 3: Scopes</a:t>
             </a:r>
           </a:p>
         </p:txBody>
@@ -8062,7 +9098,7 @@
           <a:p>
             <a:r>
               <a:rPr lang="en-US" dirty="0"/>
-              <a:t>Demo: Scopes in the Real World</a:t>
+              <a:t>Demo 4: Scopes in the Real World</a:t>
             </a:r>
           </a:p>
         </p:txBody>
@@ -8415,7 +9451,7 @@
 </file>
 
 <file path=ppt/slides/slide3.xml><?xml version="1.0" encoding="utf-8"?>
-<p:sld xmlns:a="http://schemas.openxmlformats.org/drawingml/2006/main" xmlns:r="http://schemas.openxmlformats.org/officeDocument/2006/relationships" xmlns:p="http://schemas.openxmlformats.org/presentationml/2006/main" showMasterSp="0">
+<p:sld xmlns:a="http://schemas.openxmlformats.org/drawingml/2006/main" xmlns:r="http://schemas.openxmlformats.org/officeDocument/2006/relationships" xmlns:p="http://schemas.openxmlformats.org/presentationml/2006/main" showMasterSp="0" show="0">
   <p:cSld>
     <p:spTree>
       <p:nvGrpSpPr>
@@ -8476,11 +9512,11 @@
   <p:clrMapOvr>
     <a:masterClrMapping/>
   </p:clrMapOvr>
-  <mc:AlternateContent xmlns:mc="http://schemas.openxmlformats.org/markup-compatibility/2006" xmlns:p14="http://schemas.microsoft.com/office/powerpoint/2010/main">
-    <mc:Choice Requires="p14">
+  <mc:AlternateContent xmlns:mc="http://schemas.openxmlformats.org/markup-compatibility/2006">
+    <mc:Choice xmlns:p14="http://schemas.microsoft.com/office/powerpoint/2010/main" Requires="p14">
       <p:transition p14:dur="0"/>
     </mc:Choice>
-    <mc:Fallback xmlns="">
+    <mc:Fallback>
       <p:transition/>
     </mc:Fallback>
   </mc:AlternateContent>
@@ -8926,7 +9962,7 @@
         <p:spPr>
           <a:xfrm>
             <a:off x="269239" y="1197324"/>
-            <a:ext cx="11653523" cy="632737"/>
+            <a:ext cx="11653523" cy="2823337"/>
           </a:xfrm>
         </p:spPr>
         <p:txBody>
@@ -8939,38 +9975,63 @@
             </a:pPr>
             <a:endParaRPr lang="en-US" dirty="0"/>
           </a:p>
-        </p:txBody>
-      </p:sp>
-      <p:pic>
-        <p:nvPicPr>
-          <p:cNvPr id="11" name="Picture 10">
-            <a:extLst>
-              <a:ext uri="{FF2B5EF4-FFF2-40B4-BE49-F238E27FC236}">
-                <a16:creationId xmlns:a16="http://schemas.microsoft.com/office/drawing/2014/main" id="{F2220D5E-173D-67B7-07A2-3782210ACC4E}"/>
-              </a:ext>
-            </a:extLst>
-          </p:cNvPr>
-          <p:cNvPicPr>
-            <a:picLocks noChangeAspect="1"/>
-          </p:cNvPicPr>
-          <p:nvPr/>
-        </p:nvPicPr>
-        <p:blipFill>
-          <a:blip r:embed="rId2"/>
-          <a:stretch>
-            <a:fillRect/>
-          </a:stretch>
-        </p:blipFill>
-        <p:spPr>
-          <a:xfrm>
-            <a:off x="0" y="1875146"/>
-            <a:ext cx="12192000" cy="3107708"/>
-          </a:xfrm>
-          <a:prstGeom prst="rect">
-            <a:avLst/>
-          </a:prstGeom>
-        </p:spPr>
-      </p:pic>
+          <a:p>
+            <a:pPr marL="457200" indent="-457200">
+              <a:buFontTx/>
+              <a:buChar char="-"/>
+            </a:pPr>
+            <a:r>
+              <a:rPr lang="en-US" dirty="0"/>
+              <a:t>In the beginning, there were </a:t>
+            </a:r>
+            <a:r>
+              <a:rPr lang="en-US" dirty="0" err="1"/>
+              <a:t>PerformanceCounters</a:t>
+            </a:r>
+            <a:endParaRPr lang="en-US" dirty="0"/>
+          </a:p>
+          <a:p>
+            <a:pPr marL="457200" indent="-457200">
+              <a:buFontTx/>
+              <a:buChar char="-"/>
+            </a:pPr>
+            <a:r>
+              <a:rPr lang="en-US" dirty="0" err="1"/>
+              <a:t>PerformanceCounters</a:t>
+            </a:r>
+            <a:r>
+              <a:rPr lang="en-US" dirty="0"/>
+              <a:t> were replaced by </a:t>
+            </a:r>
+            <a:r>
+              <a:rPr lang="en-US" dirty="0" err="1"/>
+              <a:t>EventCounters</a:t>
+            </a:r>
+            <a:endParaRPr lang="en-US" dirty="0"/>
+          </a:p>
+          <a:p>
+            <a:pPr marL="457200" indent="-457200">
+              <a:buFontTx/>
+              <a:buChar char="-"/>
+            </a:pPr>
+            <a:r>
+              <a:rPr lang="en-US" dirty="0" err="1"/>
+              <a:t>EventCounters</a:t>
+            </a:r>
+            <a:r>
+              <a:rPr lang="en-US" dirty="0"/>
+              <a:t> are now replaced by OTEL Metrics</a:t>
+            </a:r>
+          </a:p>
+          <a:p>
+            <a:pPr marL="457200" indent="-457200">
+              <a:buFontTx/>
+              <a:buChar char="-"/>
+            </a:pPr>
+            <a:endParaRPr lang="en-US" dirty="0"/>
+          </a:p>
+        </p:txBody>
+      </p:sp>
       <p:pic>
         <p:nvPicPr>
           <p:cNvPr id="1028" name="Picture 4">
@@ -8986,7 +10047,7 @@
           <p:nvPr/>
         </p:nvPicPr>
         <p:blipFill>
-          <a:blip r:embed="rId3">
+          <a:blip r:embed="rId2">
             <a:extLst>
               <a:ext uri="{28A0092B-C50C-407E-A947-70E740481C1C}">
                 <a14:useLocalDpi xmlns:a14="http://schemas.microsoft.com/office/drawing/2010/main" val="0"/>
@@ -9000,7 +10061,7 @@
         </p:blipFill>
         <p:spPr bwMode="auto">
           <a:xfrm>
-            <a:off x="8597356" y="4151044"/>
+            <a:off x="4433297" y="3801723"/>
             <a:ext cx="3325406" cy="2417445"/>
           </a:xfrm>
           <a:prstGeom prst="rect">
@@ -9098,7 +10159,7 @@
         <p:spPr>
           <a:xfrm>
             <a:off x="269239" y="1197324"/>
-            <a:ext cx="11653523" cy="632737"/>
+            <a:ext cx="11653523" cy="3570080"/>
           </a:xfrm>
         </p:spPr>
         <p:txBody>
@@ -9109,45 +10170,61 @@
               <a:buFontTx/>
               <a:buChar char="-"/>
             </a:pPr>
+            <a:r>
+              <a:rPr lang="en-US" dirty="0"/>
+              <a:t>ETW (Event Tracing for Windows) – extremely high-performance instrumentation across drivers et. al.</a:t>
+            </a:r>
+            <a:br>
+              <a:rPr lang="en-US" dirty="0"/>
+            </a:br>
+            <a:r>
+              <a:rPr lang="en-US" dirty="0"/>
+              <a:t>Not particularly easy to use from C#</a:t>
+            </a:r>
+          </a:p>
+          <a:p>
+            <a:pPr marL="457200" indent="-457200">
+              <a:buFontTx/>
+              <a:buChar char="-"/>
+            </a:pPr>
+            <a:r>
+              <a:rPr lang="en-US" dirty="0"/>
+              <a:t>Custom</a:t>
+            </a:r>
+          </a:p>
+          <a:p>
+            <a:pPr marL="457200" indent="-457200">
+              <a:buFontTx/>
+              <a:buChar char="-"/>
+            </a:pPr>
+            <a:r>
+              <a:rPr lang="en-US" dirty="0" err="1"/>
+              <a:t>TraceSource</a:t>
+            </a:r>
             <a:endParaRPr lang="en-US" dirty="0"/>
           </a:p>
-        </p:txBody>
-      </p:sp>
-      <p:pic>
-        <p:nvPicPr>
-          <p:cNvPr id="11" name="Picture 10">
-            <a:extLst>
-              <a:ext uri="{FF2B5EF4-FFF2-40B4-BE49-F238E27FC236}">
-                <a16:creationId xmlns:a16="http://schemas.microsoft.com/office/drawing/2014/main" id="{F2220D5E-173D-67B7-07A2-3782210ACC4E}"/>
-              </a:ext>
-            </a:extLst>
-          </p:cNvPr>
-          <p:cNvPicPr>
-            <a:picLocks noChangeAspect="1"/>
-          </p:cNvPicPr>
-          <p:nvPr/>
-        </p:nvPicPr>
-        <p:blipFill>
-          <a:blip r:embed="rId3">
-            <a:extLst>
-              <a:ext uri="{28A0092B-C50C-407E-A947-70E740481C1C}">
-                <a14:useLocalDpi xmlns:a14="http://schemas.microsoft.com/office/drawing/2010/main" val="0"/>
-              </a:ext>
-            </a:extLst>
-          </a:blip>
-          <a:srcRect/>
-          <a:stretch/>
-        </p:blipFill>
-        <p:spPr>
-          <a:xfrm>
-            <a:off x="1807" y="1875146"/>
-            <a:ext cx="12188386" cy="3107707"/>
-          </a:xfrm>
-          <a:prstGeom prst="rect">
-            <a:avLst/>
-          </a:prstGeom>
-        </p:spPr>
-      </p:pic>
+          <a:p>
+            <a:pPr marL="457200" indent="-457200">
+              <a:buFontTx/>
+              <a:buChar char="-"/>
+            </a:pPr>
+            <a:r>
+              <a:rPr lang="en-US" dirty="0"/>
+              <a:t>Modern: OTEL Traces</a:t>
+            </a:r>
+          </a:p>
+          <a:p>
+            <a:pPr marL="796926" lvl="1" indent="-457200">
+              <a:buFontTx/>
+              <a:buChar char="-"/>
+            </a:pPr>
+            <a:r>
+              <a:rPr lang="en-US" dirty="0"/>
+              <a:t>Replaces all of these.</a:t>
+            </a:r>
+          </a:p>
+        </p:txBody>
+      </p:sp>
       <p:pic>
         <p:nvPicPr>
           <p:cNvPr id="3074" name="Picture 2">
@@ -9163,7 +10240,7 @@
           <p:nvPr/>
         </p:nvPicPr>
         <p:blipFill>
-          <a:blip r:embed="rId4">
+          <a:blip r:embed="rId3">
             <a:extLst>
               <a:ext uri="{28A0092B-C50C-407E-A947-70E740481C1C}">
                 <a14:useLocalDpi xmlns:a14="http://schemas.microsoft.com/office/drawing/2010/main" val="0"/>
@@ -9177,7 +10254,7 @@
         </p:blipFill>
         <p:spPr bwMode="auto">
           <a:xfrm>
-            <a:off x="8691167" y="3851959"/>
+            <a:off x="8198798" y="2857172"/>
             <a:ext cx="3044586" cy="2716530"/>
           </a:xfrm>
           <a:prstGeom prst="rect">
@@ -9275,12 +10352,96 @@
         <p:spPr>
           <a:xfrm>
             <a:off x="269239" y="1197324"/>
-            <a:ext cx="11653523" cy="632737"/>
+            <a:ext cx="11653523" cy="5013937"/>
           </a:xfrm>
         </p:spPr>
         <p:txBody>
           <a:bodyPr/>
           <a:lstStyle/>
+          <a:p>
+            <a:pPr marL="457200" indent="-457200">
+              <a:buFontTx/>
+              <a:buChar char="-"/>
+            </a:pPr>
+            <a:r>
+              <a:rPr lang="en-US" dirty="0"/>
+              <a:t>ETW logs</a:t>
+            </a:r>
+          </a:p>
+          <a:p>
+            <a:pPr marL="457200" indent="-457200">
+              <a:buFontTx/>
+              <a:buChar char="-"/>
+            </a:pPr>
+            <a:r>
+              <a:rPr lang="en-US" dirty="0"/>
+              <a:t>Custom logs</a:t>
+            </a:r>
+          </a:p>
+          <a:p>
+            <a:pPr marL="457200" indent="-457200">
+              <a:buFontTx/>
+              <a:buChar char="-"/>
+            </a:pPr>
+            <a:r>
+              <a:rPr lang="en-US" dirty="0" err="1"/>
+              <a:t>EventLog</a:t>
+            </a:r>
+            <a:r>
+              <a:rPr lang="en-US" dirty="0"/>
+              <a:t> (particularly services)</a:t>
+            </a:r>
+          </a:p>
+          <a:p>
+            <a:pPr marL="457200" indent="-457200">
+              <a:buFontTx/>
+              <a:buChar char="-"/>
+            </a:pPr>
+            <a:r>
+              <a:rPr lang="en-US" dirty="0" err="1"/>
+              <a:t>Trace.WriteLine</a:t>
+            </a:r>
+            <a:r>
+              <a:rPr lang="en-US" dirty="0"/>
+              <a:t> – replaced by </a:t>
+            </a:r>
+            <a:r>
+              <a:rPr lang="en-US" dirty="0" err="1"/>
+              <a:t>TraceSource</a:t>
+            </a:r>
+            <a:endParaRPr lang="en-US" dirty="0"/>
+          </a:p>
+          <a:p>
+            <a:pPr marL="457200" indent="-457200">
+              <a:buFontTx/>
+              <a:buChar char="-"/>
+            </a:pPr>
+            <a:r>
+              <a:rPr lang="en-US" dirty="0" err="1"/>
+              <a:t>TraceSource</a:t>
+            </a:r>
+            <a:endParaRPr lang="en-US" dirty="0"/>
+          </a:p>
+          <a:p>
+            <a:pPr marL="457200" indent="-457200">
+              <a:buFontTx/>
+              <a:buChar char="-"/>
+            </a:pPr>
+            <a:r>
+              <a:rPr lang="en-US" dirty="0"/>
+              <a:t>Modern: OTEL logs</a:t>
+            </a:r>
+          </a:p>
+          <a:p>
+            <a:pPr marL="796926" lvl="1" indent="-457200">
+              <a:buFontTx/>
+              <a:buChar char="-"/>
+            </a:pPr>
+            <a:r>
+              <a:rPr lang="en-US" dirty="0"/>
+              <a:t>Replaces all of these</a:t>
+            </a:r>
+          </a:p>
           <a:p>
             <a:pPr marL="457200" indent="-457200">
               <a:buFontTx/>
@@ -9288,43 +10449,15 @@
             </a:pPr>
             <a:endParaRPr lang="en-US" dirty="0"/>
           </a:p>
-        </p:txBody>
-      </p:sp>
-      <p:pic>
-        <p:nvPicPr>
-          <p:cNvPr id="11" name="Picture 10">
-            <a:extLst>
-              <a:ext uri="{FF2B5EF4-FFF2-40B4-BE49-F238E27FC236}">
-                <a16:creationId xmlns:a16="http://schemas.microsoft.com/office/drawing/2014/main" id="{F2220D5E-173D-67B7-07A2-3782210ACC4E}"/>
-              </a:ext>
-            </a:extLst>
-          </p:cNvPr>
-          <p:cNvPicPr>
-            <a:picLocks noChangeAspect="1"/>
-          </p:cNvPicPr>
-          <p:nvPr/>
-        </p:nvPicPr>
-        <p:blipFill>
-          <a:blip r:embed="rId2">
-            <a:extLst>
-              <a:ext uri="{28A0092B-C50C-407E-A947-70E740481C1C}">
-                <a14:useLocalDpi xmlns:a14="http://schemas.microsoft.com/office/drawing/2010/main" val="0"/>
-              </a:ext>
-            </a:extLst>
-          </a:blip>
-          <a:srcRect/>
-          <a:stretch/>
-        </p:blipFill>
-        <p:spPr>
-          <a:xfrm>
-            <a:off x="1807" y="1875146"/>
-            <a:ext cx="12188386" cy="3107708"/>
-          </a:xfrm>
-          <a:prstGeom prst="rect">
-            <a:avLst/>
-          </a:prstGeom>
-        </p:spPr>
-      </p:pic>
+          <a:p>
+            <a:pPr marL="457200" indent="-457200">
+              <a:buFontTx/>
+              <a:buChar char="-"/>
+            </a:pPr>
+            <a:endParaRPr lang="en-US" dirty="0"/>
+          </a:p>
+        </p:txBody>
+      </p:sp>
       <p:pic>
         <p:nvPicPr>
           <p:cNvPr id="4098" name="Picture 2">
@@ -9340,7 +10473,7 @@
           <p:nvPr/>
         </p:nvPicPr>
         <p:blipFill>
-          <a:blip r:embed="rId3">
+          <a:blip r:embed="rId2">
             <a:extLst>
               <a:ext uri="{28A0092B-C50C-407E-A947-70E740481C1C}">
                 <a14:useLocalDpi xmlns:a14="http://schemas.microsoft.com/office/drawing/2010/main" val="0"/>
@@ -9354,7 +10487,7 @@
         </p:blipFill>
         <p:spPr bwMode="auto">
           <a:xfrm>
-            <a:off x="8196582" y="4084369"/>
+            <a:off x="7915228" y="3429000"/>
             <a:ext cx="3726180" cy="2484120"/>
           </a:xfrm>
           <a:prstGeom prst="rect">

</xml_diff>

<commit_message>
Load weather forecasts from MySql.
</commit_message>
<xml_diff>
--- a/Telemetry/Logging Hero.pptx
+++ b/Telemetry/Logging Hero.pptx
@@ -275,7 +275,7 @@
           <a:p>
             <a:fld id="{574E8BCA-0B4F-4373-B78E-3D2899449797}" type="datetimeFigureOut">
               <a:rPr lang="en-US" smtClean="0"/>
-              <a:t>9/11/2026</a:t>
+              <a:t>9/15/2026</a:t>
             </a:fld>
             <a:endParaRPr lang="en-US" dirty="0"/>
           </a:p>
@@ -2951,6 +2951,25 @@
               <a:rPr lang="en-US" baseline="0" dirty="0"/>
               <a:t>(undo failure code before continuing)</a:t>
             </a:r>
+          </a:p>
+          <a:p>
+            <a:pPr marL="171450" indent="-171450">
+              <a:buFont typeface="Arial" panose="020B0604020202020204" pitchFamily="34" charset="0"/>
+              <a:buChar char="•"/>
+            </a:pPr>
+            <a:r>
+              <a:rPr lang="en-US" baseline="0" dirty="0"/>
+              <a:t>(enable </a:t>
+            </a:r>
+            <a:r>
+              <a:rPr lang="en-US" baseline="0" dirty="0" err="1"/>
+              <a:t>MySqlConnector</a:t>
+            </a:r>
+            <a:r>
+              <a:rPr lang="en-US" baseline="0"/>
+              <a:t>)</a:t>
+            </a:r>
+            <a:endParaRPr lang="en-US" baseline="0" dirty="0"/>
           </a:p>
         </p:txBody>
       </p:sp>

</xml_diff>